<commit_message>
Condense research-brief deck to 9 slides (bullets for meaning/connection)
Combine 'what it means' into one bulleted slide and 'how they connect' into
two; drop filler intro slide. 15 slides down to 9.

Co-Authored-By: Claude Opus 4.8 <noreply@anthropic.com>
Claude-Session: https://claude.ai/code/session_01FhNN1xnUyELSQ3xs2X22yA
</commit_message>
<xml_diff>
--- a/content/sessions/slides/Spirituality-in-Sexuality-Research.pptx
+++ b/content/sessions/slides/Spirituality-in-Sexuality-Research.pptx
@@ -14,12 +14,6 @@
     <p:sldId id="262" r:id="rId13"/>
     <p:sldId id="263" r:id="rId14"/>
     <p:sldId id="264" r:id="rId15"/>
-    <p:sldId id="265" r:id="rId16"/>
-    <p:sldId id="266" r:id="rId17"/>
-    <p:sldId id="267" r:id="rId18"/>
-    <p:sldId id="268" r:id="rId19"/>
-    <p:sldId id="269" r:id="rId20"/>
-    <p:sldId id="270" r:id="rId21"/>
   </p:sldIdLst>
   <p:sldSz cx="12191695" cy="6858000" type="screen4x3"/>
   <p:notesSz cx="6858000" cy="9144000"/>
@@ -3303,1102 +3297,6 @@
 </p:sld>
 </file>
 
-<file path=ppt/slides/slide10.xml><?xml version="1.0" encoding="utf-8"?>
-<p:sld xmlns:a="http://schemas.openxmlformats.org/drawingml/2006/main" xmlns:p="http://schemas.openxmlformats.org/presentationml/2006/main" xmlns:r="http://schemas.openxmlformats.org/officeDocument/2006/relationships">
-  <p:cSld>
-    <p:bg>
-      <p:bgPr>
-        <a:solidFill>
-          <a:srgbClr val="FCE8EA"/>
-        </a:solidFill>
-        <a:effectLst/>
-      </p:bgPr>
-    </p:bg>
-    <p:spTree>
-      <p:nvGrpSpPr>
-        <p:cNvPr id="1" name=""/>
-        <p:cNvGrpSpPr/>
-        <p:nvPr/>
-      </p:nvGrpSpPr>
-      <p:grpSpPr/>
-      <p:sp>
-        <p:nvSpPr>
-          <p:cNvPr id="2" name="TextBox 1"/>
-          <p:cNvSpPr txBox="1"/>
-          <p:nvPr/>
-        </p:nvSpPr>
-        <p:spPr>
-          <a:xfrm>
-            <a:off x="822960" y="594360"/>
-            <a:ext cx="10515600" cy="457200"/>
-          </a:xfrm>
-          <a:prstGeom prst="rect">
-            <a:avLst/>
-          </a:prstGeom>
-          <a:noFill/>
-        </p:spPr>
-        <p:txBody>
-          <a:bodyPr wrap="none">
-            <a:spAutoFit/>
-          </a:bodyPr>
-          <a:lstStyle/>
-          <a:p>
-            <a:r>
-              <a:rPr sz="1500" b="1">
-                <a:solidFill>
-                  <a:srgbClr val="74234F"/>
-                </a:solidFill>
-                <a:latin typeface="Lora"/>
-              </a:rPr>
-              <a:t>THE EVIDENCE</a:t>
-            </a:r>
-          </a:p>
-        </p:txBody>
-      </p:sp>
-      <p:sp>
-        <p:nvSpPr>
-          <p:cNvPr id="3" name="TextBox 2"/>
-          <p:cNvSpPr txBox="1"/>
-          <p:nvPr/>
-        </p:nvSpPr>
-        <p:spPr>
-          <a:xfrm>
-            <a:off x="822960" y="1097280"/>
-            <a:ext cx="10515600" cy="2377440"/>
-          </a:xfrm>
-          <a:prstGeom prst="rect">
-            <a:avLst/>
-          </a:prstGeom>
-          <a:noFill/>
-        </p:spPr>
-        <p:txBody>
-          <a:bodyPr wrap="square" anchor="t">
-            <a:spAutoFit/>
-          </a:bodyPr>
-          <a:lstStyle/>
-          <a:p>
-            <a:r>
-              <a:rPr sz="4000">
-                <a:solidFill>
-                  <a:srgbClr val="1D283C"/>
-                </a:solidFill>
-                <a:latin typeface="Belleza"/>
-              </a:rPr>
-              <a:t>It's real, not woo</a:t>
-            </a:r>
-          </a:p>
-        </p:txBody>
-      </p:sp>
-      <p:sp>
-        <p:nvSpPr>
-          <p:cNvPr id="4" name="Rectangle 3"/>
-          <p:cNvSpPr/>
-          <p:nvPr/>
-        </p:nvSpPr>
-        <p:spPr>
-          <a:xfrm>
-            <a:off x="822960" y="2834640"/>
-            <a:ext cx="1463040" cy="38100"/>
-          </a:xfrm>
-          <a:prstGeom prst="rect">
-            <a:avLst/>
-          </a:prstGeom>
-          <a:solidFill>
-            <a:srgbClr val="74234F"/>
-          </a:solidFill>
-          <a:ln>
-            <a:noFill/>
-          </a:ln>
-          <a:effectLst/>
-        </p:spPr>
-        <p:style>
-          <a:lnRef idx="1">
-            <a:schemeClr val="accent1"/>
-          </a:lnRef>
-          <a:fillRef idx="3">
-            <a:schemeClr val="accent1"/>
-          </a:fillRef>
-          <a:effectRef idx="2">
-            <a:schemeClr val="accent1"/>
-          </a:effectRef>
-          <a:fontRef idx="minor">
-            <a:schemeClr val="lt1"/>
-          </a:fontRef>
-        </p:style>
-        <p:txBody>
-          <a:bodyPr rtlCol="0" anchor="ctr"/>
-          <a:lstStyle/>
-          <a:p>
-            <a:pPr algn="ctr"/>
-          </a:p>
-        </p:txBody>
-      </p:sp>
-      <p:sp>
-        <p:nvSpPr>
-          <p:cNvPr id="5" name="TextBox 4"/>
-          <p:cNvSpPr txBox="1"/>
-          <p:nvPr/>
-        </p:nvSpPr>
-        <p:spPr>
-          <a:xfrm>
-            <a:off x="822960" y="3154680"/>
-            <a:ext cx="10515600" cy="2926080"/>
-          </a:xfrm>
-          <a:prstGeom prst="rect">
-            <a:avLst/>
-          </a:prstGeom>
-          <a:noFill/>
-        </p:spPr>
-        <p:txBody>
-          <a:bodyPr wrap="square">
-            <a:spAutoFit/>
-          </a:bodyPr>
-          <a:lstStyle/>
-          <a:p>
-            <a:pPr>
-              <a:spcAft>
-                <a:spcPts val="1200"/>
-              </a:spcAft>
-            </a:pPr>
-            <a:r>
-              <a:rPr sz="2700" i="0">
-                <a:solidFill>
-                  <a:srgbClr val="1D283C"/>
-                </a:solidFill>
-                <a:latin typeface="Lora"/>
-              </a:rPr>
-              <a:t>Four things the research shows.</a:t>
-            </a:r>
-          </a:p>
-        </p:txBody>
-      </p:sp>
-      <p:sp>
-        <p:nvSpPr>
-          <p:cNvPr id="6" name="TextBox 5"/>
-          <p:cNvSpPr txBox="1"/>
-          <p:nvPr/>
-        </p:nvSpPr>
-        <p:spPr>
-          <a:xfrm>
-            <a:off x="822960" y="6309360"/>
-            <a:ext cx="10515600" cy="365760"/>
-          </a:xfrm>
-          <a:prstGeom prst="rect">
-            <a:avLst/>
-          </a:prstGeom>
-          <a:noFill/>
-        </p:spPr>
-        <p:txBody>
-          <a:bodyPr wrap="none">
-            <a:spAutoFit/>
-          </a:bodyPr>
-          <a:lstStyle/>
-          <a:p>
-            <a:r>
-              <a:rPr sz="1100">
-                <a:solidFill>
-                  <a:srgbClr val="74234F"/>
-                </a:solidFill>
-                <a:latin typeface="Lora"/>
-              </a:rPr>
-              <a:t>SEXUALEMPOWERMENTFORWOMEN.COM</a:t>
-            </a:r>
-          </a:p>
-        </p:txBody>
-      </p:sp>
-    </p:spTree>
-  </p:cSld>
-  <p:clrMapOvr>
-    <a:masterClrMapping/>
-  </p:clrMapOvr>
-</p:sld>
-</file>
-
-<file path=ppt/slides/slide11.xml><?xml version="1.0" encoding="utf-8"?>
-<p:sld xmlns:a="http://schemas.openxmlformats.org/drawingml/2006/main" xmlns:p="http://schemas.openxmlformats.org/presentationml/2006/main" xmlns:r="http://schemas.openxmlformats.org/officeDocument/2006/relationships">
-  <p:cSld>
-    <p:bg>
-      <p:bgPr>
-        <a:solidFill>
-          <a:srgbClr val="7CA1A5"/>
-        </a:solidFill>
-        <a:effectLst/>
-      </p:bgPr>
-    </p:bg>
-    <p:spTree>
-      <p:nvGrpSpPr>
-        <p:cNvPr id="1" name=""/>
-        <p:cNvGrpSpPr/>
-        <p:nvPr/>
-      </p:nvGrpSpPr>
-      <p:grpSpPr/>
-      <p:sp>
-        <p:nvSpPr>
-          <p:cNvPr id="2" name="TextBox 1"/>
-          <p:cNvSpPr txBox="1"/>
-          <p:nvPr/>
-        </p:nvSpPr>
-        <p:spPr>
-          <a:xfrm>
-            <a:off x="822960" y="1097280"/>
-            <a:ext cx="10515600" cy="2377440"/>
-          </a:xfrm>
-          <a:prstGeom prst="rect">
-            <a:avLst/>
-          </a:prstGeom>
-          <a:noFill/>
-        </p:spPr>
-        <p:txBody>
-          <a:bodyPr wrap="square" anchor="t">
-            <a:spAutoFit/>
-          </a:bodyPr>
-          <a:lstStyle/>
-          <a:p>
-            <a:r>
-              <a:rPr sz="4000">
-                <a:solidFill>
-                  <a:srgbClr val="1D283C"/>
-                </a:solidFill>
-                <a:latin typeface="Belleza"/>
-              </a:rPr>
-              <a:t>Presence is the skill</a:t>
-            </a:r>
-          </a:p>
-        </p:txBody>
-      </p:sp>
-      <p:sp>
-        <p:nvSpPr>
-          <p:cNvPr id="3" name="Rectangle 2"/>
-          <p:cNvSpPr/>
-          <p:nvPr/>
-        </p:nvSpPr>
-        <p:spPr>
-          <a:xfrm>
-            <a:off x="822960" y="2834640"/>
-            <a:ext cx="1463040" cy="38100"/>
-          </a:xfrm>
-          <a:prstGeom prst="rect">
-            <a:avLst/>
-          </a:prstGeom>
-          <a:solidFill>
-            <a:srgbClr val="74234F"/>
-          </a:solidFill>
-          <a:ln>
-            <a:noFill/>
-          </a:ln>
-          <a:effectLst/>
-        </p:spPr>
-        <p:style>
-          <a:lnRef idx="1">
-            <a:schemeClr val="accent1"/>
-          </a:lnRef>
-          <a:fillRef idx="3">
-            <a:schemeClr val="accent1"/>
-          </a:fillRef>
-          <a:effectRef idx="2">
-            <a:schemeClr val="accent1"/>
-          </a:effectRef>
-          <a:fontRef idx="minor">
-            <a:schemeClr val="lt1"/>
-          </a:fontRef>
-        </p:style>
-        <p:txBody>
-          <a:bodyPr rtlCol="0" anchor="ctr"/>
-          <a:lstStyle/>
-          <a:p>
-            <a:pPr algn="ctr"/>
-          </a:p>
-        </p:txBody>
-      </p:sp>
-      <p:sp>
-        <p:nvSpPr>
-          <p:cNvPr id="4" name="TextBox 3"/>
-          <p:cNvSpPr txBox="1"/>
-          <p:nvPr/>
-        </p:nvSpPr>
-        <p:spPr>
-          <a:xfrm>
-            <a:off x="822960" y="3154680"/>
-            <a:ext cx="10515600" cy="2926080"/>
-          </a:xfrm>
-          <a:prstGeom prst="rect">
-            <a:avLst/>
-          </a:prstGeom>
-          <a:noFill/>
-        </p:spPr>
-        <p:txBody>
-          <a:bodyPr wrap="square">
-            <a:spAutoFit/>
-          </a:bodyPr>
-          <a:lstStyle/>
-          <a:p>
-            <a:pPr>
-              <a:spcAft>
-                <a:spcPts val="1200"/>
-              </a:spcAft>
-            </a:pPr>
-            <a:r>
-              <a:rPr sz="2700" i="0">
-                <a:solidFill>
-                  <a:srgbClr val="1D283C"/>
-                </a:solidFill>
-                <a:latin typeface="Lora"/>
-              </a:rPr>
-              <a:t>Mindfulness measurably improves women's desire, arousal and satisfaction (Dr Lori Brotto). The spiritual muscle and the sexual one are the same: presence.</a:t>
-            </a:r>
-          </a:p>
-        </p:txBody>
-      </p:sp>
-      <p:sp>
-        <p:nvSpPr>
-          <p:cNvPr id="5" name="TextBox 4"/>
-          <p:cNvSpPr txBox="1"/>
-          <p:nvPr/>
-        </p:nvSpPr>
-        <p:spPr>
-          <a:xfrm>
-            <a:off x="822960" y="6309360"/>
-            <a:ext cx="10515600" cy="365760"/>
-          </a:xfrm>
-          <a:prstGeom prst="rect">
-            <a:avLst/>
-          </a:prstGeom>
-          <a:noFill/>
-        </p:spPr>
-        <p:txBody>
-          <a:bodyPr wrap="none">
-            <a:spAutoFit/>
-          </a:bodyPr>
-          <a:lstStyle/>
-          <a:p>
-            <a:r>
-              <a:rPr sz="1100">
-                <a:solidFill>
-                  <a:srgbClr val="74234F"/>
-                </a:solidFill>
-                <a:latin typeface="Lora"/>
-              </a:rPr>
-              <a:t>SEXUALEMPOWERMENTFORWOMEN.COM</a:t>
-            </a:r>
-          </a:p>
-        </p:txBody>
-      </p:sp>
-    </p:spTree>
-  </p:cSld>
-  <p:clrMapOvr>
-    <a:masterClrMapping/>
-  </p:clrMapOvr>
-</p:sld>
-</file>
-
-<file path=ppt/slides/slide12.xml><?xml version="1.0" encoding="utf-8"?>
-<p:sld xmlns:a="http://schemas.openxmlformats.org/drawingml/2006/main" xmlns:p="http://schemas.openxmlformats.org/presentationml/2006/main" xmlns:r="http://schemas.openxmlformats.org/officeDocument/2006/relationships">
-  <p:cSld>
-    <p:bg>
-      <p:bgPr>
-        <a:solidFill>
-          <a:srgbClr val="1D283C"/>
-        </a:solidFill>
-        <a:effectLst/>
-      </p:bgPr>
-    </p:bg>
-    <p:spTree>
-      <p:nvGrpSpPr>
-        <p:cNvPr id="1" name=""/>
-        <p:cNvGrpSpPr/>
-        <p:nvPr/>
-      </p:nvGrpSpPr>
-      <p:grpSpPr/>
-      <p:sp>
-        <p:nvSpPr>
-          <p:cNvPr id="2" name="TextBox 1"/>
-          <p:cNvSpPr txBox="1"/>
-          <p:nvPr/>
-        </p:nvSpPr>
-        <p:spPr>
-          <a:xfrm>
-            <a:off x="822960" y="1097280"/>
-            <a:ext cx="10515600" cy="2377440"/>
-          </a:xfrm>
-          <a:prstGeom prst="rect">
-            <a:avLst/>
-          </a:prstGeom>
-          <a:noFill/>
-        </p:spPr>
-        <p:txBody>
-          <a:bodyPr wrap="square" anchor="t">
-            <a:spAutoFit/>
-          </a:bodyPr>
-          <a:lstStyle/>
-          <a:p>
-            <a:r>
-              <a:rPr sz="4000">
-                <a:solidFill>
-                  <a:srgbClr val="FCE8EA"/>
-                </a:solidFill>
-                <a:latin typeface="Belleza"/>
-              </a:rPr>
-              <a:t>Union is literal</a:t>
-            </a:r>
-          </a:p>
-        </p:txBody>
-      </p:sp>
-      <p:sp>
-        <p:nvSpPr>
-          <p:cNvPr id="3" name="Rectangle 2"/>
-          <p:cNvSpPr/>
-          <p:nvPr/>
-        </p:nvSpPr>
-        <p:spPr>
-          <a:xfrm>
-            <a:off x="822960" y="2834640"/>
-            <a:ext cx="1463040" cy="38100"/>
-          </a:xfrm>
-          <a:prstGeom prst="rect">
-            <a:avLst/>
-          </a:prstGeom>
-          <a:solidFill>
-            <a:srgbClr val="C9A86D"/>
-          </a:solidFill>
-          <a:ln>
-            <a:noFill/>
-          </a:ln>
-          <a:effectLst/>
-        </p:spPr>
-        <p:style>
-          <a:lnRef idx="1">
-            <a:schemeClr val="accent1"/>
-          </a:lnRef>
-          <a:fillRef idx="3">
-            <a:schemeClr val="accent1"/>
-          </a:fillRef>
-          <a:effectRef idx="2">
-            <a:schemeClr val="accent1"/>
-          </a:effectRef>
-          <a:fontRef idx="minor">
-            <a:schemeClr val="lt1"/>
-          </a:fontRef>
-        </p:style>
-        <p:txBody>
-          <a:bodyPr rtlCol="0" anchor="ctr"/>
-          <a:lstStyle/>
-          <a:p>
-            <a:pPr algn="ctr"/>
-          </a:p>
-        </p:txBody>
-      </p:sp>
-      <p:sp>
-        <p:nvSpPr>
-          <p:cNvPr id="4" name="TextBox 3"/>
-          <p:cNvSpPr txBox="1"/>
-          <p:nvPr/>
-        </p:nvSpPr>
-        <p:spPr>
-          <a:xfrm>
-            <a:off x="822960" y="3154680"/>
-            <a:ext cx="10515600" cy="2926080"/>
-          </a:xfrm>
-          <a:prstGeom prst="rect">
-            <a:avLst/>
-          </a:prstGeom>
-          <a:noFill/>
-        </p:spPr>
-        <p:txBody>
-          <a:bodyPr wrap="square">
-            <a:spAutoFit/>
-          </a:bodyPr>
-          <a:lstStyle/>
-          <a:p>
-            <a:pPr>
-              <a:spcAft>
-                <a:spcPts val="1200"/>
-              </a:spcAft>
-            </a:pPr>
-            <a:r>
-              <a:rPr sz="2700" i="0">
-                <a:solidFill>
-                  <a:srgbClr val="FCE8EA"/>
-                </a:solidFill>
-                <a:latin typeface="Lora"/>
-              </a:rPr>
-              <a:t>In eye-gaze studies, two people's brains, even their blinking, begin to synchronise, and they feel closer. Becoming one isn't only poetry.</a:t>
-            </a:r>
-          </a:p>
-        </p:txBody>
-      </p:sp>
-      <p:sp>
-        <p:nvSpPr>
-          <p:cNvPr id="5" name="TextBox 4"/>
-          <p:cNvSpPr txBox="1"/>
-          <p:nvPr/>
-        </p:nvSpPr>
-        <p:spPr>
-          <a:xfrm>
-            <a:off x="822960" y="6309360"/>
-            <a:ext cx="10515600" cy="365760"/>
-          </a:xfrm>
-          <a:prstGeom prst="rect">
-            <a:avLst/>
-          </a:prstGeom>
-          <a:noFill/>
-        </p:spPr>
-        <p:txBody>
-          <a:bodyPr wrap="none">
-            <a:spAutoFit/>
-          </a:bodyPr>
-          <a:lstStyle/>
-          <a:p>
-            <a:r>
-              <a:rPr sz="1100">
-                <a:solidFill>
-                  <a:srgbClr val="C9A86D"/>
-                </a:solidFill>
-                <a:latin typeface="Lora"/>
-              </a:rPr>
-              <a:t>SEXUALEMPOWERMENTFORWOMEN.COM</a:t>
-            </a:r>
-          </a:p>
-        </p:txBody>
-      </p:sp>
-    </p:spTree>
-  </p:cSld>
-  <p:clrMapOvr>
-    <a:masterClrMapping/>
-  </p:clrMapOvr>
-</p:sld>
-</file>
-
-<file path=ppt/slides/slide13.xml><?xml version="1.0" encoding="utf-8"?>
-<p:sld xmlns:a="http://schemas.openxmlformats.org/drawingml/2006/main" xmlns:p="http://schemas.openxmlformats.org/presentationml/2006/main" xmlns:r="http://schemas.openxmlformats.org/officeDocument/2006/relationships">
-  <p:cSld>
-    <p:bg>
-      <p:bgPr>
-        <a:solidFill>
-          <a:srgbClr val="74234F"/>
-        </a:solidFill>
-        <a:effectLst/>
-      </p:bgPr>
-    </p:bg>
-    <p:spTree>
-      <p:nvGrpSpPr>
-        <p:cNvPr id="1" name=""/>
-        <p:cNvGrpSpPr/>
-        <p:nvPr/>
-      </p:nvGrpSpPr>
-      <p:grpSpPr/>
-      <p:sp>
-        <p:nvSpPr>
-          <p:cNvPr id="2" name="TextBox 1"/>
-          <p:cNvSpPr txBox="1"/>
-          <p:nvPr/>
-        </p:nvSpPr>
-        <p:spPr>
-          <a:xfrm>
-            <a:off x="822960" y="1097280"/>
-            <a:ext cx="10515600" cy="2377440"/>
-          </a:xfrm>
-          <a:prstGeom prst="rect">
-            <a:avLst/>
-          </a:prstGeom>
-          <a:noFill/>
-        </p:spPr>
-        <p:txBody>
-          <a:bodyPr wrap="square" anchor="t">
-            <a:spAutoFit/>
-          </a:bodyPr>
-          <a:lstStyle/>
-          <a:p>
-            <a:r>
-              <a:rPr sz="4000">
-                <a:solidFill>
-                  <a:srgbClr val="FCE8EA"/>
-                </a:solidFill>
-                <a:latin typeface="Belleza"/>
-              </a:rPr>
-              <a:t>A chemistry of the sacred</a:t>
-            </a:r>
-          </a:p>
-        </p:txBody>
-      </p:sp>
-      <p:sp>
-        <p:nvSpPr>
-          <p:cNvPr id="3" name="Rectangle 2"/>
-          <p:cNvSpPr/>
-          <p:nvPr/>
-        </p:nvSpPr>
-        <p:spPr>
-          <a:xfrm>
-            <a:off x="822960" y="2834640"/>
-            <a:ext cx="1463040" cy="38100"/>
-          </a:xfrm>
-          <a:prstGeom prst="rect">
-            <a:avLst/>
-          </a:prstGeom>
-          <a:solidFill>
-            <a:srgbClr val="C9A86D"/>
-          </a:solidFill>
-          <a:ln>
-            <a:noFill/>
-          </a:ln>
-          <a:effectLst/>
-        </p:spPr>
-        <p:style>
-          <a:lnRef idx="1">
-            <a:schemeClr val="accent1"/>
-          </a:lnRef>
-          <a:fillRef idx="3">
-            <a:schemeClr val="accent1"/>
-          </a:fillRef>
-          <a:effectRef idx="2">
-            <a:schemeClr val="accent1"/>
-          </a:effectRef>
-          <a:fontRef idx="minor">
-            <a:schemeClr val="lt1"/>
-          </a:fontRef>
-        </p:style>
-        <p:txBody>
-          <a:bodyPr rtlCol="0" anchor="ctr"/>
-          <a:lstStyle/>
-          <a:p>
-            <a:pPr algn="ctr"/>
-          </a:p>
-        </p:txBody>
-      </p:sp>
-      <p:sp>
-        <p:nvSpPr>
-          <p:cNvPr id="4" name="TextBox 3"/>
-          <p:cNvSpPr txBox="1"/>
-          <p:nvPr/>
-        </p:nvSpPr>
-        <p:spPr>
-          <a:xfrm>
-            <a:off x="822960" y="3154680"/>
-            <a:ext cx="10515600" cy="2926080"/>
-          </a:xfrm>
-          <a:prstGeom prst="rect">
-            <a:avLst/>
-          </a:prstGeom>
-          <a:noFill/>
-        </p:spPr>
-        <p:txBody>
-          <a:bodyPr wrap="square">
-            <a:spAutoFit/>
-          </a:bodyPr>
-          <a:lstStyle/>
-          <a:p>
-            <a:pPr>
-              <a:spcAft>
-                <a:spcPts val="1200"/>
-              </a:spcAft>
-            </a:pPr>
-            <a:r>
-              <a:rPr sz="2700" i="0">
-                <a:solidFill>
-                  <a:srgbClr val="FCE8EA"/>
-                </a:solidFill>
-                <a:latin typeface="Lora"/>
-              </a:rPr>
-              <a:t>Touch and intimacy release oxytocin, dopamine and endorphins: bonding, trust, dissolved boundaries, the afterglow.</a:t>
-            </a:r>
-          </a:p>
-        </p:txBody>
-      </p:sp>
-      <p:sp>
-        <p:nvSpPr>
-          <p:cNvPr id="5" name="TextBox 4"/>
-          <p:cNvSpPr txBox="1"/>
-          <p:nvPr/>
-        </p:nvSpPr>
-        <p:spPr>
-          <a:xfrm>
-            <a:off x="822960" y="6309360"/>
-            <a:ext cx="10515600" cy="365760"/>
-          </a:xfrm>
-          <a:prstGeom prst="rect">
-            <a:avLst/>
-          </a:prstGeom>
-          <a:noFill/>
-        </p:spPr>
-        <p:txBody>
-          <a:bodyPr wrap="none">
-            <a:spAutoFit/>
-          </a:bodyPr>
-          <a:lstStyle/>
-          <a:p>
-            <a:r>
-              <a:rPr sz="1100">
-                <a:solidFill>
-                  <a:srgbClr val="C9A86D"/>
-                </a:solidFill>
-                <a:latin typeface="Lora"/>
-              </a:rPr>
-              <a:t>SEXUALEMPOWERMENTFORWOMEN.COM</a:t>
-            </a:r>
-          </a:p>
-        </p:txBody>
-      </p:sp>
-    </p:spTree>
-  </p:cSld>
-  <p:clrMapOvr>
-    <a:masterClrMapping/>
-  </p:clrMapOvr>
-</p:sld>
-</file>
-
-<file path=ppt/slides/slide14.xml><?xml version="1.0" encoding="utf-8"?>
-<p:sld xmlns:a="http://schemas.openxmlformats.org/drawingml/2006/main" xmlns:p="http://schemas.openxmlformats.org/presentationml/2006/main" xmlns:r="http://schemas.openxmlformats.org/officeDocument/2006/relationships">
-  <p:cSld>
-    <p:bg>
-      <p:bgPr>
-        <a:solidFill>
-          <a:srgbClr val="E4BBC2"/>
-        </a:solidFill>
-        <a:effectLst/>
-      </p:bgPr>
-    </p:bg>
-    <p:spTree>
-      <p:nvGrpSpPr>
-        <p:cNvPr id="1" name=""/>
-        <p:cNvGrpSpPr/>
-        <p:nvPr/>
-      </p:nvGrpSpPr>
-      <p:grpSpPr/>
-      <p:sp>
-        <p:nvSpPr>
-          <p:cNvPr id="2" name="TextBox 1"/>
-          <p:cNvSpPr txBox="1"/>
-          <p:nvPr/>
-        </p:nvSpPr>
-        <p:spPr>
-          <a:xfrm>
-            <a:off x="822960" y="1097280"/>
-            <a:ext cx="10515600" cy="2377440"/>
-          </a:xfrm>
-          <a:prstGeom prst="rect">
-            <a:avLst/>
-          </a:prstGeom>
-          <a:noFill/>
-        </p:spPr>
-        <p:txBody>
-          <a:bodyPr wrap="square" anchor="t">
-            <a:spAutoFit/>
-          </a:bodyPr>
-          <a:lstStyle/>
-          <a:p>
-            <a:r>
-              <a:rPr sz="4000">
-                <a:solidFill>
-                  <a:srgbClr val="1D283C"/>
-                </a:solidFill>
-                <a:latin typeface="Belleza"/>
-              </a:rPr>
-              <a:t>Vulnerability is the gateway</a:t>
-            </a:r>
-          </a:p>
-        </p:txBody>
-      </p:sp>
-      <p:sp>
-        <p:nvSpPr>
-          <p:cNvPr id="3" name="Rectangle 2"/>
-          <p:cNvSpPr/>
-          <p:nvPr/>
-        </p:nvSpPr>
-        <p:spPr>
-          <a:xfrm>
-            <a:off x="822960" y="2834640"/>
-            <a:ext cx="1463040" cy="38100"/>
-          </a:xfrm>
-          <a:prstGeom prst="rect">
-            <a:avLst/>
-          </a:prstGeom>
-          <a:solidFill>
-            <a:srgbClr val="74234F"/>
-          </a:solidFill>
-          <a:ln>
-            <a:noFill/>
-          </a:ln>
-          <a:effectLst/>
-        </p:spPr>
-        <p:style>
-          <a:lnRef idx="1">
-            <a:schemeClr val="accent1"/>
-          </a:lnRef>
-          <a:fillRef idx="3">
-            <a:schemeClr val="accent1"/>
-          </a:fillRef>
-          <a:effectRef idx="2">
-            <a:schemeClr val="accent1"/>
-          </a:effectRef>
-          <a:fontRef idx="minor">
-            <a:schemeClr val="lt1"/>
-          </a:fontRef>
-        </p:style>
-        <p:txBody>
-          <a:bodyPr rtlCol="0" anchor="ctr"/>
-          <a:lstStyle/>
-          <a:p>
-            <a:pPr algn="ctr"/>
-          </a:p>
-        </p:txBody>
-      </p:sp>
-      <p:sp>
-        <p:nvSpPr>
-          <p:cNvPr id="4" name="TextBox 3"/>
-          <p:cNvSpPr txBox="1"/>
-          <p:nvPr/>
-        </p:nvSpPr>
-        <p:spPr>
-          <a:xfrm>
-            <a:off x="822960" y="3154680"/>
-            <a:ext cx="10515600" cy="2926080"/>
-          </a:xfrm>
-          <a:prstGeom prst="rect">
-            <a:avLst/>
-          </a:prstGeom>
-          <a:noFill/>
-        </p:spPr>
-        <p:txBody>
-          <a:bodyPr wrap="square">
-            <a:spAutoFit/>
-          </a:bodyPr>
-          <a:lstStyle/>
-          <a:p>
-            <a:pPr>
-              <a:spcAft>
-                <a:spcPts val="1200"/>
-              </a:spcAft>
-            </a:pPr>
-            <a:r>
-              <a:rPr sz="2700" i="0">
-                <a:solidFill>
-                  <a:srgbClr val="1D283C"/>
-                </a:solidFill>
-                <a:latin typeface="Lora"/>
-              </a:rPr>
-              <a:t>Being truly seen is tied to the deepest connection, the same vulnerability the traditions call surrender.</a:t>
-            </a:r>
-          </a:p>
-        </p:txBody>
-      </p:sp>
-      <p:sp>
-        <p:nvSpPr>
-          <p:cNvPr id="5" name="TextBox 4"/>
-          <p:cNvSpPr txBox="1"/>
-          <p:nvPr/>
-        </p:nvSpPr>
-        <p:spPr>
-          <a:xfrm>
-            <a:off x="822960" y="6309360"/>
-            <a:ext cx="10515600" cy="365760"/>
-          </a:xfrm>
-          <a:prstGeom prst="rect">
-            <a:avLst/>
-          </a:prstGeom>
-          <a:noFill/>
-        </p:spPr>
-        <p:txBody>
-          <a:bodyPr wrap="none">
-            <a:spAutoFit/>
-          </a:bodyPr>
-          <a:lstStyle/>
-          <a:p>
-            <a:r>
-              <a:rPr sz="1100">
-                <a:solidFill>
-                  <a:srgbClr val="74234F"/>
-                </a:solidFill>
-                <a:latin typeface="Lora"/>
-              </a:rPr>
-              <a:t>SEXUALEMPOWERMENTFORWOMEN.COM</a:t>
-            </a:r>
-          </a:p>
-        </p:txBody>
-      </p:sp>
-    </p:spTree>
-  </p:cSld>
-  <p:clrMapOvr>
-    <a:masterClrMapping/>
-  </p:clrMapOvr>
-</p:sld>
-</file>
-
-<file path=ppt/slides/slide15.xml><?xml version="1.0" encoding="utf-8"?>
-<p:sld xmlns:a="http://schemas.openxmlformats.org/drawingml/2006/main" xmlns:p="http://schemas.openxmlformats.org/presentationml/2006/main" xmlns:r="http://schemas.openxmlformats.org/officeDocument/2006/relationships">
-  <p:cSld>
-    <p:bg>
-      <p:bgPr>
-        <a:solidFill>
-          <a:srgbClr val="1D283C"/>
-        </a:solidFill>
-        <a:effectLst/>
-      </p:bgPr>
-    </p:bg>
-    <p:spTree>
-      <p:nvGrpSpPr>
-        <p:cNvPr id="1" name=""/>
-        <p:cNvGrpSpPr/>
-        <p:nvPr/>
-      </p:nvGrpSpPr>
-      <p:grpSpPr/>
-      <p:sp>
-        <p:nvSpPr>
-          <p:cNvPr id="2" name="TextBox 1"/>
-          <p:cNvSpPr txBox="1"/>
-          <p:nvPr/>
-        </p:nvSpPr>
-        <p:spPr>
-          <a:xfrm>
-            <a:off x="822960" y="1097280"/>
-            <a:ext cx="10515600" cy="2377440"/>
-          </a:xfrm>
-          <a:prstGeom prst="rect">
-            <a:avLst/>
-          </a:prstGeom>
-          <a:noFill/>
-        </p:spPr>
-        <p:txBody>
-          <a:bodyPr wrap="square" anchor="t">
-            <a:spAutoFit/>
-          </a:bodyPr>
-          <a:lstStyle/>
-          <a:p>
-            <a:r>
-              <a:rPr sz="5200">
-                <a:solidFill>
-                  <a:srgbClr val="FCE8EA"/>
-                </a:solidFill>
-                <a:latin typeface="Belleza"/>
-              </a:rPr>
-              <a:t>The body isn't the obstacle</a:t>
-            </a:r>
-          </a:p>
-        </p:txBody>
-      </p:sp>
-      <p:sp>
-        <p:nvSpPr>
-          <p:cNvPr id="3" name="Rectangle 2"/>
-          <p:cNvSpPr/>
-          <p:nvPr/>
-        </p:nvSpPr>
-        <p:spPr>
-          <a:xfrm>
-            <a:off x="822960" y="3749040"/>
-            <a:ext cx="1463040" cy="38100"/>
-          </a:xfrm>
-          <a:prstGeom prst="rect">
-            <a:avLst/>
-          </a:prstGeom>
-          <a:solidFill>
-            <a:srgbClr val="C9A86D"/>
-          </a:solidFill>
-          <a:ln>
-            <a:noFill/>
-          </a:ln>
-          <a:effectLst/>
-        </p:spPr>
-        <p:style>
-          <a:lnRef idx="1">
-            <a:schemeClr val="accent1"/>
-          </a:lnRef>
-          <a:fillRef idx="3">
-            <a:schemeClr val="accent1"/>
-          </a:fillRef>
-          <a:effectRef idx="2">
-            <a:schemeClr val="accent1"/>
-          </a:effectRef>
-          <a:fontRef idx="minor">
-            <a:schemeClr val="lt1"/>
-          </a:fontRef>
-        </p:style>
-        <p:txBody>
-          <a:bodyPr rtlCol="0" anchor="ctr"/>
-          <a:lstStyle/>
-          <a:p>
-            <a:pPr algn="ctr"/>
-          </a:p>
-        </p:txBody>
-      </p:sp>
-      <p:sp>
-        <p:nvSpPr>
-          <p:cNvPr id="4" name="TextBox 3"/>
-          <p:cNvSpPr txBox="1"/>
-          <p:nvPr/>
-        </p:nvSpPr>
-        <p:spPr>
-          <a:xfrm>
-            <a:off x="822960" y="4069080"/>
-            <a:ext cx="10515600" cy="2926080"/>
-          </a:xfrm>
-          <a:prstGeom prst="rect">
-            <a:avLst/>
-          </a:prstGeom>
-          <a:noFill/>
-        </p:spPr>
-        <p:txBody>
-          <a:bodyPr wrap="square">
-            <a:spAutoFit/>
-          </a:bodyPr>
-          <a:lstStyle/>
-          <a:p>
-            <a:pPr>
-              <a:spcAft>
-                <a:spcPts val="1200"/>
-              </a:spcAft>
-            </a:pPr>
-            <a:r>
-              <a:rPr sz="2700" i="0">
-                <a:solidFill>
-                  <a:srgbClr val="FCE8EA"/>
-                </a:solidFill>
-                <a:latin typeface="Lora"/>
-              </a:rPr>
-              <a:t>Received as a gift, it's the doorway to the sacred.</a:t>
-            </a:r>
-          </a:p>
-        </p:txBody>
-      </p:sp>
-      <p:sp>
-        <p:nvSpPr>
-          <p:cNvPr id="5" name="TextBox 4"/>
-          <p:cNvSpPr txBox="1"/>
-          <p:nvPr/>
-        </p:nvSpPr>
-        <p:spPr>
-          <a:xfrm>
-            <a:off x="822960" y="6309360"/>
-            <a:ext cx="10515600" cy="365760"/>
-          </a:xfrm>
-          <a:prstGeom prst="rect">
-            <a:avLst/>
-          </a:prstGeom>
-          <a:noFill/>
-        </p:spPr>
-        <p:txBody>
-          <a:bodyPr wrap="none">
-            <a:spAutoFit/>
-          </a:bodyPr>
-          <a:lstStyle/>
-          <a:p>
-            <a:r>
-              <a:rPr sz="1100">
-                <a:solidFill>
-                  <a:srgbClr val="C9A86D"/>
-                </a:solidFill>
-                <a:latin typeface="Lora"/>
-              </a:rPr>
-              <a:t>SEXUALEMPOWERMENTFORWOMEN.COM</a:t>
-            </a:r>
-          </a:p>
-        </p:txBody>
-      </p:sp>
-    </p:spTree>
-  </p:cSld>
-  <p:clrMapOvr>
-    <a:masterClrMapping/>
-  </p:clrMapOvr>
-</p:sld>
-</file>
-
 <file path=ppt/slides/slide2.xml><?xml version="1.0" encoding="utf-8"?>
 <p:sld xmlns:a="http://schemas.openxmlformats.org/drawingml/2006/main" xmlns:p="http://schemas.openxmlformats.org/presentationml/2006/main" xmlns:r="http://schemas.openxmlformats.org/officeDocument/2006/relationships">
   <p:cSld>
@@ -4446,7 +3344,7 @@
                 </a:solidFill>
                 <a:latin typeface="Lora"/>
               </a:rPr>
-              <a:t>WHAT IT ACTUALLY MEANS</a:t>
+              <a:t>WHAT IT MEANS</a:t>
             </a:r>
           </a:p>
         </p:txBody>
@@ -4480,7 +3378,7 @@
                 </a:solidFill>
                 <a:latin typeface="Belleza"/>
               </a:rPr>
-              <a:t>Sacred sexuality</a:t>
+              <a:t>What sacred sexuality means</a:t>
             </a:r>
           </a:p>
         </p:txBody>
@@ -4557,13 +3455,45 @@
               </a:spcAft>
             </a:pPr>
             <a:r>
-              <a:rPr sz="2700" i="0">
+              <a:rPr sz="2400" i="0">
                 <a:solidFill>
                   <a:srgbClr val="1D283C"/>
                 </a:solidFill>
                 <a:latin typeface="Lora"/>
               </a:rPr>
-              <a:t>Bringing intention, presence and reverence to sex, so it becomes more than a physical act.</a:t>
+              <a:t>•  Bringing intention, presence and reverence to sex, so it's more than a physical act.</a:t>
+            </a:r>
+          </a:p>
+          <a:p>
+            <a:pPr>
+              <a:spcAft>
+                <a:spcPts val="1200"/>
+              </a:spcAft>
+            </a:pPr>
+            <a:r>
+              <a:rPr sz="2400" i="0">
+                <a:solidFill>
+                  <a:srgbClr val="1D283C"/>
+                </a:solidFill>
+                <a:latin typeface="Lora"/>
+              </a:rPr>
+              <a:t>•  A doorway to something larger than you: the divine, life force, oneness, love.</a:t>
+            </a:r>
+          </a:p>
+          <a:p>
+            <a:pPr>
+              <a:spcAft>
+                <a:spcPts val="1200"/>
+              </a:spcAft>
+            </a:pPr>
+            <a:r>
+              <a:rPr sz="2400" i="0">
+                <a:solidFill>
+                  <a:srgbClr val="1D283C"/>
+                </a:solidFill>
+                <a:latin typeface="Lora"/>
+              </a:rPr>
+              <a:t>•  The act doesn't change. The awareness you bring does. Communion, not performance.</a:t>
             </a:r>
           </a:p>
         </p:txBody>
@@ -4611,6 +3541,265 @@
 </file>
 
 <file path=ppt/slides/slide3.xml><?xml version="1.0" encoding="utf-8"?>
+<p:sld xmlns:a="http://schemas.openxmlformats.org/drawingml/2006/main" xmlns:p="http://schemas.openxmlformats.org/presentationml/2006/main" xmlns:r="http://schemas.openxmlformats.org/officeDocument/2006/relationships">
+  <p:cSld>
+    <p:bg>
+      <p:bgPr>
+        <a:solidFill>
+          <a:srgbClr val="224652"/>
+        </a:solidFill>
+        <a:effectLst/>
+      </p:bgPr>
+    </p:bg>
+    <p:spTree>
+      <p:nvGrpSpPr>
+        <p:cNvPr id="1" name=""/>
+        <p:cNvGrpSpPr/>
+        <p:nvPr/>
+      </p:nvGrpSpPr>
+      <p:grpSpPr/>
+      <p:sp>
+        <p:nvSpPr>
+          <p:cNvPr id="2" name="TextBox 1"/>
+          <p:cNvSpPr txBox="1"/>
+          <p:nvPr/>
+        </p:nvSpPr>
+        <p:spPr>
+          <a:xfrm>
+            <a:off x="822960" y="594360"/>
+            <a:ext cx="10515600" cy="457200"/>
+          </a:xfrm>
+          <a:prstGeom prst="rect">
+            <a:avLst/>
+          </a:prstGeom>
+          <a:noFill/>
+        </p:spPr>
+        <p:txBody>
+          <a:bodyPr wrap="none">
+            <a:spAutoFit/>
+          </a:bodyPr>
+          <a:lstStyle/>
+          <a:p>
+            <a:r>
+              <a:rPr sz="1500" b="1">
+                <a:solidFill>
+                  <a:srgbClr val="C9A86D"/>
+                </a:solidFill>
+                <a:latin typeface="Lora"/>
+              </a:rPr>
+              <a:t>HOW THEY CONNECT</a:t>
+            </a:r>
+          </a:p>
+        </p:txBody>
+      </p:sp>
+      <p:sp>
+        <p:nvSpPr>
+          <p:cNvPr id="3" name="TextBox 2"/>
+          <p:cNvSpPr txBox="1"/>
+          <p:nvPr/>
+        </p:nvSpPr>
+        <p:spPr>
+          <a:xfrm>
+            <a:off x="822960" y="1097280"/>
+            <a:ext cx="10515600" cy="2377440"/>
+          </a:xfrm>
+          <a:prstGeom prst="rect">
+            <a:avLst/>
+          </a:prstGeom>
+          <a:noFill/>
+        </p:spPr>
+        <p:txBody>
+          <a:bodyPr wrap="square" anchor="t">
+            <a:spAutoFit/>
+          </a:bodyPr>
+          <a:lstStyle/>
+          <a:p>
+            <a:r>
+              <a:rPr sz="4000">
+                <a:solidFill>
+                  <a:srgbClr val="FCE8EA"/>
+                </a:solidFill>
+                <a:latin typeface="Belleza"/>
+              </a:rPr>
+              <a:t>The same longing</a:t>
+            </a:r>
+          </a:p>
+        </p:txBody>
+      </p:sp>
+      <p:sp>
+        <p:nvSpPr>
+          <p:cNvPr id="4" name="Rectangle 3"/>
+          <p:cNvSpPr/>
+          <p:nvPr/>
+        </p:nvSpPr>
+        <p:spPr>
+          <a:xfrm>
+            <a:off x="822960" y="2834640"/>
+            <a:ext cx="1463040" cy="38100"/>
+          </a:xfrm>
+          <a:prstGeom prst="rect">
+            <a:avLst/>
+          </a:prstGeom>
+          <a:solidFill>
+            <a:srgbClr val="C9A86D"/>
+          </a:solidFill>
+          <a:ln>
+            <a:noFill/>
+          </a:ln>
+          <a:effectLst/>
+        </p:spPr>
+        <p:style>
+          <a:lnRef idx="1">
+            <a:schemeClr val="accent1"/>
+          </a:lnRef>
+          <a:fillRef idx="3">
+            <a:schemeClr val="accent1"/>
+          </a:fillRef>
+          <a:effectRef idx="2">
+            <a:schemeClr val="accent1"/>
+          </a:effectRef>
+          <a:fontRef idx="minor">
+            <a:schemeClr val="lt1"/>
+          </a:fontRef>
+        </p:style>
+        <p:txBody>
+          <a:bodyPr rtlCol="0" anchor="ctr"/>
+          <a:lstStyle/>
+          <a:p>
+            <a:pPr algn="ctr"/>
+          </a:p>
+        </p:txBody>
+      </p:sp>
+      <p:sp>
+        <p:nvSpPr>
+          <p:cNvPr id="5" name="TextBox 4"/>
+          <p:cNvSpPr txBox="1"/>
+          <p:nvPr/>
+        </p:nvSpPr>
+        <p:spPr>
+          <a:xfrm>
+            <a:off x="822960" y="3154680"/>
+            <a:ext cx="10515600" cy="2926080"/>
+          </a:xfrm>
+          <a:prstGeom prst="rect">
+            <a:avLst/>
+          </a:prstGeom>
+          <a:noFill/>
+        </p:spPr>
+        <p:txBody>
+          <a:bodyPr wrap="square">
+            <a:spAutoFit/>
+          </a:bodyPr>
+          <a:lstStyle/>
+          <a:p>
+            <a:pPr>
+              <a:spcAft>
+                <a:spcPts val="1200"/>
+              </a:spcAft>
+            </a:pPr>
+            <a:r>
+              <a:rPr sz="2400" i="0">
+                <a:solidFill>
+                  <a:srgbClr val="FCE8EA"/>
+                </a:solidFill>
+                <a:latin typeface="Lora"/>
+              </a:rPr>
+              <a:t>•  Both spring from the same root: desire and longing.</a:t>
+            </a:r>
+          </a:p>
+          <a:p>
+            <a:pPr>
+              <a:spcAft>
+                <a:spcPts val="1200"/>
+              </a:spcAft>
+            </a:pPr>
+            <a:r>
+              <a:rPr sz="2400" i="0">
+                <a:solidFill>
+                  <a:srgbClr val="FCE8EA"/>
+                </a:solidFill>
+                <a:latin typeface="Lora"/>
+              </a:rPr>
+              <a:t>•  Sexuality: the longing to know and be known, to merge with another.</a:t>
+            </a:r>
+          </a:p>
+          <a:p>
+            <a:pPr>
+              <a:spcAft>
+                <a:spcPts val="1200"/>
+              </a:spcAft>
+            </a:pPr>
+            <a:r>
+              <a:rPr sz="2400" i="0">
+                <a:solidFill>
+                  <a:srgbClr val="FCE8EA"/>
+                </a:solidFill>
+                <a:latin typeface="Lora"/>
+              </a:rPr>
+              <a:t>•  Spirituality: the same longing, pointed at the whole, to belong to something greater.</a:t>
+            </a:r>
+          </a:p>
+          <a:p>
+            <a:pPr>
+              <a:spcAft>
+                <a:spcPts val="1200"/>
+              </a:spcAft>
+            </a:pPr>
+            <a:r>
+              <a:rPr sz="2400" i="0">
+                <a:solidFill>
+                  <a:srgbClr val="FCE8EA"/>
+                </a:solidFill>
+                <a:latin typeface="Lora"/>
+              </a:rPr>
+              <a:t>•  Two directions, one yearning, to end separateness.</a:t>
+            </a:r>
+          </a:p>
+        </p:txBody>
+      </p:sp>
+      <p:sp>
+        <p:nvSpPr>
+          <p:cNvPr id="6" name="TextBox 5"/>
+          <p:cNvSpPr txBox="1"/>
+          <p:nvPr/>
+        </p:nvSpPr>
+        <p:spPr>
+          <a:xfrm>
+            <a:off x="822960" y="6309360"/>
+            <a:ext cx="10515600" cy="365760"/>
+          </a:xfrm>
+          <a:prstGeom prst="rect">
+            <a:avLst/>
+          </a:prstGeom>
+          <a:noFill/>
+        </p:spPr>
+        <p:txBody>
+          <a:bodyPr wrap="none">
+            <a:spAutoFit/>
+          </a:bodyPr>
+          <a:lstStyle/>
+          <a:p>
+            <a:r>
+              <a:rPr sz="1100">
+                <a:solidFill>
+                  <a:srgbClr val="C9A86D"/>
+                </a:solidFill>
+                <a:latin typeface="Lora"/>
+              </a:rPr>
+              <a:t>SEXUALEMPOWERMENTFORWOMEN.COM</a:t>
+            </a:r>
+          </a:p>
+        </p:txBody>
+      </p:sp>
+    </p:spTree>
+  </p:cSld>
+  <p:clrMapOvr>
+    <a:masterClrMapping/>
+  </p:clrMapOvr>
+</p:sld>
+</file>
+
+<file path=ppt/slides/slide4.xml><?xml version="1.0" encoding="utf-8"?>
 <p:sld xmlns:a="http://schemas.openxmlformats.org/drawingml/2006/main" xmlns:p="http://schemas.openxmlformats.org/presentationml/2006/main" xmlns:r="http://schemas.openxmlformats.org/officeDocument/2006/relationships">
   <p:cSld>
     <p:bg>
@@ -4657,7 +3846,7 @@
                 </a:solidFill>
                 <a:latin typeface="Belleza"/>
               </a:rPr>
-              <a:t>A doorway</a:t>
+              <a:t>The body is the doorway</a:t>
             </a:r>
           </a:p>
         </p:txBody>
@@ -4734,13 +3923,45 @@
               </a:spcAft>
             </a:pPr>
             <a:r>
-              <a:rPr sz="2700" i="0">
+              <a:rPr sz="2400" i="0">
                 <a:solidFill>
                   <a:srgbClr val="FCE8EA"/>
                 </a:solidFill>
                 <a:latin typeface="Lora"/>
               </a:rPr>
-              <a:t>A way to connect with something larger than yourself: the divine, life force, oneness, love, spirit. Name it however you like.</a:t>
+              <a:t>•  Tantra never split them. Body-shameful, spirit-holy is the wound, not the truth.</a:t>
+            </a:r>
+          </a:p>
+          <a:p>
+            <a:pPr>
+              <a:spcAft>
+                <a:spcPts val="1200"/>
+              </a:spcAft>
+            </a:pPr>
+            <a:r>
+              <a:rPr sz="2400" i="0">
+                <a:solidFill>
+                  <a:srgbClr val="FCE8EA"/>
+                </a:solidFill>
+                <a:latin typeface="Lora"/>
+              </a:rPr>
+              <a:t>•  Transcendence, like pleasure, moves through the body, not around it.</a:t>
+            </a:r>
+          </a:p>
+          <a:p>
+            <a:pPr>
+              <a:spcAft>
+                <a:spcPts val="1200"/>
+              </a:spcAft>
+            </a:pPr>
+            <a:r>
+              <a:rPr sz="2400" i="0">
+                <a:solidFill>
+                  <a:srgbClr val="FCE8EA"/>
+                </a:solidFill>
+                <a:latin typeface="Lora"/>
+              </a:rPr>
+              <a:t>•  You reach the sacred by going in, not rising above. Bypassing can't get you there.</a:t>
             </a:r>
           </a:p>
         </p:txBody>
@@ -4787,13 +4008,13 @@
 </p:sld>
 </file>
 
-<file path=ppt/slides/slide4.xml><?xml version="1.0" encoding="utf-8"?>
+<file path=ppt/slides/slide5.xml><?xml version="1.0" encoding="utf-8"?>
 <p:sld xmlns:a="http://schemas.openxmlformats.org/drawingml/2006/main" xmlns:p="http://schemas.openxmlformats.org/presentationml/2006/main" xmlns:r="http://schemas.openxmlformats.org/officeDocument/2006/relationships">
   <p:cSld>
     <p:bg>
       <p:bgPr>
         <a:solidFill>
-          <a:srgbClr val="E4BBC2"/>
+          <a:srgbClr val="7CA1A5"/>
         </a:solidFill>
         <a:effectLst/>
       </p:bgPr>
@@ -4813,8 +4034,8 @@
         </p:nvSpPr>
         <p:spPr>
           <a:xfrm>
-            <a:off x="822960" y="1097280"/>
-            <a:ext cx="10515600" cy="2377440"/>
+            <a:off x="822960" y="594360"/>
+            <a:ext cx="10515600" cy="457200"/>
           </a:xfrm>
           <a:prstGeom prst="rect">
             <a:avLst/>
@@ -4822,6 +4043,40 @@
           <a:noFill/>
         </p:spPr>
         <p:txBody>
+          <a:bodyPr wrap="none">
+            <a:spAutoFit/>
+          </a:bodyPr>
+          <a:lstStyle/>
+          <a:p>
+            <a:r>
+              <a:rPr sz="1500" b="1">
+                <a:solidFill>
+                  <a:srgbClr val="74234F"/>
+                </a:solidFill>
+                <a:latin typeface="Lora"/>
+              </a:rPr>
+              <a:t>THE EVIDENCE · IT'S REAL, NOT WOO</a:t>
+            </a:r>
+          </a:p>
+        </p:txBody>
+      </p:sp>
+      <p:sp>
+        <p:nvSpPr>
+          <p:cNvPr id="3" name="TextBox 2"/>
+          <p:cNvSpPr txBox="1"/>
+          <p:nvPr/>
+        </p:nvSpPr>
+        <p:spPr>
+          <a:xfrm>
+            <a:off x="822960" y="1097280"/>
+            <a:ext cx="10515600" cy="2377440"/>
+          </a:xfrm>
+          <a:prstGeom prst="rect">
+            <a:avLst/>
+          </a:prstGeom>
+          <a:noFill/>
+        </p:spPr>
+        <p:txBody>
           <a:bodyPr wrap="square" anchor="t">
             <a:spAutoFit/>
           </a:bodyPr>
@@ -4834,14 +4089,14 @@
                 </a:solidFill>
                 <a:latin typeface="Belleza"/>
               </a:rPr>
-              <a:t>The act doesn't change</a:t>
-            </a:r>
-          </a:p>
-        </p:txBody>
-      </p:sp>
-      <p:sp>
-        <p:nvSpPr>
-          <p:cNvPr id="3" name="Rectangle 2"/>
+              <a:t>Presence is the skill</a:t>
+            </a:r>
+          </a:p>
+        </p:txBody>
+      </p:sp>
+      <p:sp>
+        <p:nvSpPr>
+          <p:cNvPr id="4" name="Rectangle 3"/>
           <p:cNvSpPr/>
           <p:nvPr/>
         </p:nvSpPr>
@@ -4885,7 +4140,7 @@
       </p:sp>
       <p:sp>
         <p:nvSpPr>
-          <p:cNvPr id="4" name="TextBox 3"/>
+          <p:cNvPr id="5" name="TextBox 4"/>
           <p:cNvSpPr txBox="1"/>
           <p:nvPr/>
         </p:nvSpPr>
@@ -4917,14 +4172,14 @@
                 </a:solidFill>
                 <a:latin typeface="Lora"/>
               </a:rPr>
-              <a:t>The awareness you bring to it does. Approached with presence, sex becomes communion, not performance or transaction.</a:t>
-            </a:r>
-          </a:p>
-        </p:txBody>
-      </p:sp>
-      <p:sp>
-        <p:nvSpPr>
-          <p:cNvPr id="5" name="TextBox 4"/>
+              <a:t>Mindfulness measurably improves women's desire, arousal and satisfaction (Dr Lori Brotto). The spiritual muscle and the sexual one are the same: presence.</a:t>
+            </a:r>
+          </a:p>
+        </p:txBody>
+      </p:sp>
+      <p:sp>
+        <p:nvSpPr>
+          <p:cNvPr id="6" name="TextBox 5"/>
           <p:cNvSpPr txBox="1"/>
           <p:nvPr/>
         </p:nvSpPr>
@@ -4964,7 +4219,7 @@
 </p:sld>
 </file>
 
-<file path=ppt/slides/slide5.xml><?xml version="1.0" encoding="utf-8"?>
+<file path=ppt/slides/slide6.xml><?xml version="1.0" encoding="utf-8"?>
 <p:sld xmlns:a="http://schemas.openxmlformats.org/drawingml/2006/main" xmlns:p="http://schemas.openxmlformats.org/presentationml/2006/main" xmlns:r="http://schemas.openxmlformats.org/officeDocument/2006/relationships">
   <p:cSld>
     <p:bg>
@@ -4990,8 +4245,8 @@
         </p:nvSpPr>
         <p:spPr>
           <a:xfrm>
-            <a:off x="822960" y="594360"/>
-            <a:ext cx="10515600" cy="457200"/>
+            <a:off x="822960" y="1097280"/>
+            <a:ext cx="10515600" cy="2377440"/>
           </a:xfrm>
           <a:prstGeom prst="rect">
             <a:avLst/>
@@ -4999,40 +4254,6 @@
           <a:noFill/>
         </p:spPr>
         <p:txBody>
-          <a:bodyPr wrap="none">
-            <a:spAutoFit/>
-          </a:bodyPr>
-          <a:lstStyle/>
-          <a:p>
-            <a:r>
-              <a:rPr sz="1500" b="1">
-                <a:solidFill>
-                  <a:srgbClr val="C9A86D"/>
-                </a:solidFill>
-                <a:latin typeface="Lora"/>
-              </a:rPr>
-              <a:t>HOW THEY CONNECT</a:t>
-            </a:r>
-          </a:p>
-        </p:txBody>
-      </p:sp>
-      <p:sp>
-        <p:nvSpPr>
-          <p:cNvPr id="3" name="TextBox 2"/>
-          <p:cNvSpPr txBox="1"/>
-          <p:nvPr/>
-        </p:nvSpPr>
-        <p:spPr>
-          <a:xfrm>
-            <a:off x="822960" y="1097280"/>
-            <a:ext cx="10515600" cy="2377440"/>
-          </a:xfrm>
-          <a:prstGeom prst="rect">
-            <a:avLst/>
-          </a:prstGeom>
-          <a:noFill/>
-        </p:spPr>
-        <p:txBody>
           <a:bodyPr wrap="square" anchor="t">
             <a:spAutoFit/>
           </a:bodyPr>
@@ -5045,14 +4266,14 @@
                 </a:solidFill>
                 <a:latin typeface="Belleza"/>
               </a:rPr>
-              <a:t>The same root</a:t>
-            </a:r>
-          </a:p>
-        </p:txBody>
-      </p:sp>
-      <p:sp>
-        <p:nvSpPr>
-          <p:cNvPr id="4" name="Rectangle 3"/>
+              <a:t>Union is literal</a:t>
+            </a:r>
+          </a:p>
+        </p:txBody>
+      </p:sp>
+      <p:sp>
+        <p:nvSpPr>
+          <p:cNvPr id="3" name="Rectangle 2"/>
           <p:cNvSpPr/>
           <p:nvPr/>
         </p:nvSpPr>
@@ -5096,7 +4317,7 @@
       </p:sp>
       <p:sp>
         <p:nvSpPr>
-          <p:cNvPr id="5" name="TextBox 4"/>
+          <p:cNvPr id="4" name="TextBox 3"/>
           <p:cNvSpPr txBox="1"/>
           <p:nvPr/>
         </p:nvSpPr>
@@ -5128,184 +4349,7 @@
                 </a:solidFill>
                 <a:latin typeface="Lora"/>
               </a:rPr>
-              <a:t>Sexuality and spirituality spring from the same place: desire and longing.</a:t>
-            </a:r>
-          </a:p>
-        </p:txBody>
-      </p:sp>
-      <p:sp>
-        <p:nvSpPr>
-          <p:cNvPr id="6" name="TextBox 5"/>
-          <p:cNvSpPr txBox="1"/>
-          <p:nvPr/>
-        </p:nvSpPr>
-        <p:spPr>
-          <a:xfrm>
-            <a:off x="822960" y="6309360"/>
-            <a:ext cx="10515600" cy="365760"/>
-          </a:xfrm>
-          <a:prstGeom prst="rect">
-            <a:avLst/>
-          </a:prstGeom>
-          <a:noFill/>
-        </p:spPr>
-        <p:txBody>
-          <a:bodyPr wrap="none">
-            <a:spAutoFit/>
-          </a:bodyPr>
-          <a:lstStyle/>
-          <a:p>
-            <a:r>
-              <a:rPr sz="1100">
-                <a:solidFill>
-                  <a:srgbClr val="C9A86D"/>
-                </a:solidFill>
-                <a:latin typeface="Lora"/>
-              </a:rPr>
-              <a:t>SEXUALEMPOWERMENTFORWOMEN.COM</a:t>
-            </a:r>
-          </a:p>
-        </p:txBody>
-      </p:sp>
-    </p:spTree>
-  </p:cSld>
-  <p:clrMapOvr>
-    <a:masterClrMapping/>
-  </p:clrMapOvr>
-</p:sld>
-</file>
-
-<file path=ppt/slides/slide6.xml><?xml version="1.0" encoding="utf-8"?>
-<p:sld xmlns:a="http://schemas.openxmlformats.org/drawingml/2006/main" xmlns:p="http://schemas.openxmlformats.org/presentationml/2006/main" xmlns:r="http://schemas.openxmlformats.org/officeDocument/2006/relationships">
-  <p:cSld>
-    <p:bg>
-      <p:bgPr>
-        <a:solidFill>
-          <a:srgbClr val="224652"/>
-        </a:solidFill>
-        <a:effectLst/>
-      </p:bgPr>
-    </p:bg>
-    <p:spTree>
-      <p:nvGrpSpPr>
-        <p:cNvPr id="1" name=""/>
-        <p:cNvGrpSpPr/>
-        <p:nvPr/>
-      </p:nvGrpSpPr>
-      <p:grpSpPr/>
-      <p:sp>
-        <p:nvSpPr>
-          <p:cNvPr id="2" name="TextBox 1"/>
-          <p:cNvSpPr txBox="1"/>
-          <p:nvPr/>
-        </p:nvSpPr>
-        <p:spPr>
-          <a:xfrm>
-            <a:off x="822960" y="1097280"/>
-            <a:ext cx="10515600" cy="2377440"/>
-          </a:xfrm>
-          <a:prstGeom prst="rect">
-            <a:avLst/>
-          </a:prstGeom>
-          <a:noFill/>
-        </p:spPr>
-        <p:txBody>
-          <a:bodyPr wrap="square" anchor="t">
-            <a:spAutoFit/>
-          </a:bodyPr>
-          <a:lstStyle/>
-          <a:p>
-            <a:r>
-              <a:rPr sz="4000">
-                <a:solidFill>
-                  <a:srgbClr val="FCE8EA"/>
-                </a:solidFill>
-                <a:latin typeface="Belleza"/>
-              </a:rPr>
-              <a:t>Sexuality</a:t>
-            </a:r>
-          </a:p>
-        </p:txBody>
-      </p:sp>
-      <p:sp>
-        <p:nvSpPr>
-          <p:cNvPr id="3" name="Rectangle 2"/>
-          <p:cNvSpPr/>
-          <p:nvPr/>
-        </p:nvSpPr>
-        <p:spPr>
-          <a:xfrm>
-            <a:off x="822960" y="2834640"/>
-            <a:ext cx="1463040" cy="38100"/>
-          </a:xfrm>
-          <a:prstGeom prst="rect">
-            <a:avLst/>
-          </a:prstGeom>
-          <a:solidFill>
-            <a:srgbClr val="C9A86D"/>
-          </a:solidFill>
-          <a:ln>
-            <a:noFill/>
-          </a:ln>
-          <a:effectLst/>
-        </p:spPr>
-        <p:style>
-          <a:lnRef idx="1">
-            <a:schemeClr val="accent1"/>
-          </a:lnRef>
-          <a:fillRef idx="3">
-            <a:schemeClr val="accent1"/>
-          </a:fillRef>
-          <a:effectRef idx="2">
-            <a:schemeClr val="accent1"/>
-          </a:effectRef>
-          <a:fontRef idx="minor">
-            <a:schemeClr val="lt1"/>
-          </a:fontRef>
-        </p:style>
-        <p:txBody>
-          <a:bodyPr rtlCol="0" anchor="ctr"/>
-          <a:lstStyle/>
-          <a:p>
-            <a:pPr algn="ctr"/>
-          </a:p>
-        </p:txBody>
-      </p:sp>
-      <p:sp>
-        <p:nvSpPr>
-          <p:cNvPr id="4" name="TextBox 3"/>
-          <p:cNvSpPr txBox="1"/>
-          <p:nvPr/>
-        </p:nvSpPr>
-        <p:spPr>
-          <a:xfrm>
-            <a:off x="822960" y="3154680"/>
-            <a:ext cx="10515600" cy="2926080"/>
-          </a:xfrm>
-          <a:prstGeom prst="rect">
-            <a:avLst/>
-          </a:prstGeom>
-          <a:noFill/>
-        </p:spPr>
-        <p:txBody>
-          <a:bodyPr wrap="square">
-            <a:spAutoFit/>
-          </a:bodyPr>
-          <a:lstStyle/>
-          <a:p>
-            <a:pPr>
-              <a:spcAft>
-                <a:spcPts val="1200"/>
-              </a:spcAft>
-            </a:pPr>
-            <a:r>
-              <a:rPr sz="2700" i="0">
-                <a:solidFill>
-                  <a:srgbClr val="FCE8EA"/>
-                </a:solidFill>
-                <a:latin typeface="Lora"/>
-              </a:rPr>
-              <a:t>The longing to know and be known. To connect with, merge with, and be met by another, body, heart and soul.</a:t>
+              <a:t>In eye-gaze studies, two people's brains, even their blinking, begin to synchronise, and they feel closer. Becoming one isn't only poetry.</a:t>
             </a:r>
           </a:p>
         </p:txBody>
@@ -5399,7 +4443,7 @@
                 </a:solidFill>
                 <a:latin typeface="Belleza"/>
               </a:rPr>
-              <a:t>Spirituality</a:t>
+              <a:t>A chemistry of the sacred</a:t>
             </a:r>
           </a:p>
         </p:txBody>
@@ -5482,7 +4526,7 @@
                 </a:solidFill>
                 <a:latin typeface="Lora"/>
               </a:rPr>
-              <a:t>The same longing, pointed at the whole. To dissolve into, and belong to, something greater.</a:t>
+              <a:t>Touch and intimacy release oxytocin, dopamine and endorphins: bonding, trust, dissolved boundaries, the afterglow.</a:t>
             </a:r>
           </a:p>
         </p:txBody>
@@ -5535,7 +4579,7 @@
     <p:bg>
       <p:bgPr>
         <a:solidFill>
-          <a:srgbClr val="74234F"/>
+          <a:srgbClr val="E4BBC2"/>
         </a:solidFill>
         <a:effectLst/>
       </p:bgPr>
@@ -5572,11 +4616,11 @@
             <a:r>
               <a:rPr sz="4000">
                 <a:solidFill>
-                  <a:srgbClr val="FCE8EA"/>
+                  <a:srgbClr val="1D283C"/>
                 </a:solidFill>
                 <a:latin typeface="Belleza"/>
               </a:rPr>
-              <a:t>Two directions, one longing</a:t>
+              <a:t>Vulnerability is the gateway</a:t>
             </a:r>
           </a:p>
         </p:txBody>
@@ -5596,7 +4640,7 @@
             <a:avLst/>
           </a:prstGeom>
           <a:solidFill>
-            <a:srgbClr val="C9A86D"/>
+            <a:srgbClr val="74234F"/>
           </a:solidFill>
           <a:ln>
             <a:noFill/>
@@ -5655,11 +4699,11 @@
             <a:r>
               <a:rPr sz="2700" i="0">
                 <a:solidFill>
-                  <a:srgbClr val="FCE8EA"/>
+                  <a:srgbClr val="1D283C"/>
                 </a:solidFill>
                 <a:latin typeface="Lora"/>
               </a:rPr>
-              <a:t>The yearning to end separateness. Tantra never split them. Body-shameful, spirit-holy is the wound, not the truth. Two sides of one coin.</a:t>
+              <a:t>Being truly seen is tied to the deepest connection, the same vulnerability the traditions call surrender.</a:t>
             </a:r>
           </a:p>
         </p:txBody>
@@ -5689,7 +4733,7 @@
             <a:r>
               <a:rPr sz="1100">
                 <a:solidFill>
-                  <a:srgbClr val="C9A86D"/>
+                  <a:srgbClr val="74234F"/>
                 </a:solidFill>
                 <a:latin typeface="Lora"/>
               </a:rPr>
@@ -5747,13 +4791,13 @@
           <a:lstStyle/>
           <a:p>
             <a:r>
-              <a:rPr sz="4000">
+              <a:rPr sz="5200">
                 <a:solidFill>
                   <a:srgbClr val="FCE8EA"/>
                 </a:solidFill>
                 <a:latin typeface="Belleza"/>
               </a:rPr>
-              <a:t>The body is the doorway</a:t>
+              <a:t>The body isn't the obstacle</a:t>
             </a:r>
           </a:p>
         </p:txBody>
@@ -5766,7 +4810,7 @@
         </p:nvSpPr>
         <p:spPr>
           <a:xfrm>
-            <a:off x="822960" y="2834640"/>
+            <a:off x="822960" y="3749040"/>
             <a:ext cx="1463040" cy="38100"/>
           </a:xfrm>
           <a:prstGeom prst="rect">
@@ -5810,7 +4854,7 @@
         </p:nvSpPr>
         <p:spPr>
           <a:xfrm>
-            <a:off x="822960" y="3154680"/>
+            <a:off x="822960" y="4069080"/>
             <a:ext cx="10515600" cy="2926080"/>
           </a:xfrm>
           <a:prstGeom prst="rect">
@@ -5836,7 +4880,7 @@
                 </a:solidFill>
                 <a:latin typeface="Lora"/>
               </a:rPr>
-              <a:t>Transcendence, like pleasure, moves through the body, not around it. You reach the sacred by going in, not rising above.</a:t>
+              <a:t>Received as a gift, it's the doorway to the sacred.</a:t>
             </a:r>
           </a:p>
         </p:txBody>

</xml_diff>